<commit_message>
🎬 Pitch Deck v4.1 — pipeline warm, ask €100K, range €90-150K
- Trazione: pipeline warm unificata (Mario Cucciolito · Gruppo Amodio · Farmacia Tanzillo · NaturaSì Vomero)
- Fundraising: Ask €100.000 · Range €90K–€150K
</commit_message>
<xml_diff>
--- a/02-INVESTOR-PRESENTATIONS/DLOOP_Pitch_Deck_2026.pptx
+++ b/02-INVESTOR-PRESENTATIONS/DLOOP_Pitch_Deck_2026.pptx
@@ -2464,7 +2464,7 @@
                   <a:srgbClr val="FFFFFF"/>
                 </a:solidFill>
               </a:rPr>
-              <a:t>€ 80.000 – € 100.000</a:t>
+              <a:t>€ 90.000 – € 150.000</a:t>
             </a:r>
             <a:endParaRPr lang="en-US" sz="1000" dirty="0"/>
           </a:p>
@@ -3422,27 +3422,7 @@
                 <a:ea typeface="Georgia" pitchFamily="34" charset="-122"/>
                 <a:cs typeface="Georgia" pitchFamily="34" charset="-120"/>
               </a:rPr>
-              <a:t>€80K–€100K seed.</a:t>
-            </a:r>
-            <a:endParaRPr lang="en-US" sz="3400" dirty="0"/>
-          </a:p>
-          <a:p>
-            <a:pPr indent="0" marL="0">
-              <a:lnSpc>
-                <a:spcPct val="110000"/>
-              </a:lnSpc>
-              <a:buNone/>
-            </a:pPr>
-            <a:r>
-              <a:rPr lang="en-US" sz="3400" b="1" dirty="0">
-                <a:solidFill>
-                  <a:srgbClr val="FFFFFF"/>
-                </a:solidFill>
-                <a:latin typeface="Georgia" pitchFamily="34" charset="0"/>
-                <a:ea typeface="Georgia" pitchFamily="34" charset="-122"/>
-                <a:cs typeface="Georgia" pitchFamily="34" charset="-120"/>
-              </a:rPr>
-              <a:t>Runway 16 mesi verso break-even.</a:t>
+              <a:t>€100K seed  |  Range €90K–€150K  |  Runway 16 mesi</a:t>
             </a:r>
             <a:endParaRPr lang="en-US" sz="3400" dirty="0"/>
           </a:p>
@@ -3541,7 +3521,7 @@
               <a:buNone/>
             </a:pPr>
             <a:r>
-              <a:rPr lang="en-US" sz="4200" b="1" dirty="0">
+              <a:rPr lang="en-US" sz="3800" b="1" dirty="0">
                 <a:solidFill>
                   <a:srgbClr val="14B8A6"/>
                 </a:solidFill>
@@ -3549,9 +3529,9 @@
                 <a:ea typeface="Georgia" pitchFamily="34" charset="-122"/>
                 <a:cs typeface="Georgia" pitchFamily="34" charset="-120"/>
               </a:rPr>
-              <a:t>€90.000</a:t>
-            </a:r>
-            <a:endParaRPr lang="en-US" sz="4200" dirty="0"/>
+              <a:t>€100.000</a:t>
+            </a:r>
+            <a:endParaRPr lang="en-US" sz="3800" dirty="0"/>
           </a:p>
         </p:txBody>
       </p:sp>
@@ -3585,7 +3565,7 @@
                   <a:srgbClr val="8CB3CC"/>
                 </a:solidFill>
               </a:rPr>
-              <a:t>(range €80K – €100K)</a:t>
+              <a:t>(range €90K – €150K)</a:t>
             </a:r>
             <a:endParaRPr lang="en-US" sz="1000" dirty="0"/>
           </a:p>
@@ -17756,7 +17736,7 @@
                   <a:srgbClr val="FFFFFF"/>
                 </a:solidFill>
               </a:rPr>
-              <a:t>Pipeline warm: 3-5 merchant certi a M1</a:t>
+              <a:t>Pipeline warm: 6+ merchant certi a M1</a:t>
             </a:r>
             <a:endParaRPr lang="en-US" sz="1000" dirty="0"/>
           </a:p>
@@ -17795,7 +17775,7 @@
                   <a:srgbClr val="8CB3CC"/>
                 </a:solidFill>
               </a:rPr>
-              <a:t>CEO outreach diretto. Mario Cucciolito (Pet) e rete personale Pomigliano/Napoli. Zero paid ads M1-M4.</a:t>
+              <a:t>Mario Cucciolito (Pet Shop) · Gruppo Amodio (Supermercati Pam) · Farmacia Tanzillo · NaturaSì Vomero. Rete personale Pomigliano/Napoli. Zero paid ads M1-M4.</a:t>
             </a:r>
             <a:endParaRPr lang="en-US" sz="900" dirty="0"/>
           </a:p>
@@ -18216,6 +18196,131 @@
             <a:avLst/>
           </a:prstGeom>
           <a:solidFill>
+            <a:srgbClr val="F59E0B"/>
+          </a:solidFill>
+          <a:ln w="12700">
+            <a:solidFill>
+              <a:srgbClr val="F59E0B"/>
+            </a:solidFill>
+            <a:prstDash val="solid"/>
+          </a:ln>
+        </p:spPr>
+      </p:sp>
+      <p:sp>
+        <p:nvSpPr>
+          <p:cNvPr id="30" name="Text 28"/>
+          <p:cNvSpPr/>
+          <p:nvPr/>
+        </p:nvSpPr>
+        <p:spPr>
+          <a:xfrm>
+            <a:off x="6629400" y="4032504"/>
+            <a:ext cx="4937760" cy="274320"/>
+          </a:xfrm>
+          <a:prstGeom prst="rect">
+            <a:avLst/>
+          </a:prstGeom>
+          <a:noFill/>
+          <a:ln/>
+        </p:spPr>
+        <p:txBody>
+          <a:bodyPr wrap="square" lIns="0" tIns="0" rIns="0" bIns="0" rtlCol="0" anchor="ctr"/>
+          <a:lstStyle/>
+          <a:p>
+            <a:pPr indent="0" marL="0">
+              <a:buNone/>
+            </a:pPr>
+            <a:r>
+              <a:rPr lang="en-US" sz="1000" b="1" dirty="0">
+                <a:solidFill>
+                  <a:srgbClr val="FFFFFF"/>
+                </a:solidFill>
+              </a:rPr>
+              <a:t>Verifica Twilio in corso (Case #1380112390587406)</a:t>
+            </a:r>
+            <a:endParaRPr lang="en-US" sz="1000" dirty="0"/>
+          </a:p>
+        </p:txBody>
+      </p:sp>
+      <p:sp>
+        <p:nvSpPr>
+          <p:cNvPr id="31" name="Text 29"/>
+          <p:cNvSpPr/>
+          <p:nvPr/>
+        </p:nvSpPr>
+        <p:spPr>
+          <a:xfrm>
+            <a:off x="6629400" y="4325112"/>
+            <a:ext cx="4937760" cy="512064"/>
+          </a:xfrm>
+          <a:prstGeom prst="rect">
+            <a:avLst/>
+          </a:prstGeom>
+          <a:noFill/>
+          <a:ln/>
+        </p:spPr>
+        <p:txBody>
+          <a:bodyPr wrap="square" lIns="0" tIns="0" rIns="0" bIns="0" rtlCol="0" anchor="ctr"/>
+          <a:lstStyle/>
+          <a:p>
+            <a:pPr indent="0" marL="0">
+              <a:lnSpc>
+                <a:spcPct val="135000"/>
+              </a:lnSpc>
+              <a:buNone/>
+            </a:pPr>
+            <a:r>
+              <a:rPr lang="en-US" sz="900" dirty="0">
+                <a:solidFill>
+                  <a:srgbClr val="8CB3CC"/>
+                </a:solidFill>
+              </a:rPr>
+              <a:t>Documentazione inviata. Fallback alternativo pronto. WhatsApp Business API operativa entro 15gg.</a:t>
+            </a:r>
+            <a:endParaRPr lang="en-US" sz="900" dirty="0"/>
+          </a:p>
+        </p:txBody>
+      </p:sp>
+      <p:sp>
+        <p:nvSpPr>
+          <p:cNvPr id="32" name="Shape 30"/>
+          <p:cNvSpPr/>
+          <p:nvPr/>
+        </p:nvSpPr>
+        <p:spPr>
+          <a:xfrm>
+            <a:off x="6217920" y="5029200"/>
+            <a:ext cx="5486400" cy="960120"/>
+          </a:xfrm>
+          <a:prstGeom prst="rect">
+            <a:avLst/>
+          </a:prstGeom>
+          <a:solidFill>
+            <a:srgbClr val="0F2535"/>
+          </a:solidFill>
+          <a:ln w="12700">
+            <a:solidFill>
+              <a:srgbClr val="1A3A50"/>
+            </a:solidFill>
+            <a:prstDash val="solid"/>
+          </a:ln>
+        </p:spPr>
+      </p:sp>
+      <p:sp>
+        <p:nvSpPr>
+          <p:cNvPr id="33" name="Shape 31"/>
+          <p:cNvSpPr/>
+          <p:nvPr/>
+        </p:nvSpPr>
+        <p:spPr>
+          <a:xfrm>
+            <a:off x="6355080" y="5321808"/>
+            <a:ext cx="164592" cy="164592"/>
+          </a:xfrm>
+          <a:prstGeom prst="ellipse">
+            <a:avLst/>
+          </a:prstGeom>
+          <a:solidFill>
             <a:srgbClr val="0B7A75"/>
           </a:solidFill>
           <a:ln w="12700">
@@ -18228,13 +18333,13 @@
       </p:sp>
       <p:sp>
         <p:nvSpPr>
-          <p:cNvPr id="30" name="Text 28"/>
-          <p:cNvSpPr/>
-          <p:nvPr/>
-        </p:nvSpPr>
-        <p:spPr>
-          <a:xfrm>
-            <a:off x="6629400" y="4032504"/>
+          <p:cNvPr id="34" name="Text 32"/>
+          <p:cNvSpPr/>
+          <p:nvPr/>
+        </p:nvSpPr>
+        <p:spPr>
+          <a:xfrm>
+            <a:off x="6629400" y="5084064"/>
             <a:ext cx="4937760" cy="274320"/>
           </a:xfrm>
           <a:prstGeom prst="rect">
@@ -18256,7 +18361,7 @@
                   <a:srgbClr val="FFFFFF"/>
                 </a:solidFill>
               </a:rPr>
-              <a:t>Gruppo Amodio — Supermercati Pam (Pomigliano/Napoli)</a:t>
+              <a:t>GitHub pubblico con pitch deck live</a:t>
             </a:r>
             <a:endParaRPr lang="en-US" sz="1000" dirty="0"/>
           </a:p>
@@ -18264,13 +18369,13 @@
       </p:sp>
       <p:sp>
         <p:nvSpPr>
-          <p:cNvPr id="31" name="Text 29"/>
-          <p:cNvSpPr/>
-          <p:nvPr/>
-        </p:nvSpPr>
-        <p:spPr>
-          <a:xfrm>
-            <a:off x="6629400" y="4325112"/>
+          <p:cNvPr id="35" name="Text 33"/>
+          <p:cNvSpPr/>
+          <p:nvPr/>
+        </p:nvSpPr>
+        <p:spPr>
+          <a:xfrm>
+            <a:off x="6629400" y="5376672"/>
             <a:ext cx="4937760" cy="512064"/>
           </a:xfrm>
           <a:prstGeom prst="rect">
@@ -18295,7 +18400,7 @@
                   <a:srgbClr val="8CB3CC"/>
                 </a:solidFill>
               </a:rPr>
-              <a:t>Grocery: supermercati catena Pam sul territorio. Pipeline B2B Operator, alto volume ordini.</a:t>
+              <a:t>github.com/creamoj-ai/dloop-pitch-deck — due diligence tecnica aperta. GitHub Pages attivo.</a:t>
             </a:r>
             <a:endParaRPr lang="en-US" sz="900" dirty="0"/>
           </a:p>
@@ -18303,507 +18408,7 @@
       </p:sp>
       <p:sp>
         <p:nvSpPr>
-          <p:cNvPr id="32" name="Shape 30"/>
-          <p:cNvSpPr/>
-          <p:nvPr/>
-        </p:nvSpPr>
-        <p:spPr>
-          <a:xfrm>
-            <a:off x="6217920" y="5029200"/>
-            <a:ext cx="5486400" cy="960120"/>
-          </a:xfrm>
-          <a:prstGeom prst="rect">
-            <a:avLst/>
-          </a:prstGeom>
-          <a:solidFill>
-            <a:srgbClr val="0F2535"/>
-          </a:solidFill>
-          <a:ln w="12700">
-            <a:solidFill>
-              <a:srgbClr val="1A3A50"/>
-            </a:solidFill>
-            <a:prstDash val="solid"/>
-          </a:ln>
-        </p:spPr>
-      </p:sp>
-      <p:sp>
-        <p:nvSpPr>
-          <p:cNvPr id="33" name="Shape 31"/>
-          <p:cNvSpPr/>
-          <p:nvPr/>
-        </p:nvSpPr>
-        <p:spPr>
-          <a:xfrm>
-            <a:off x="6355080" y="5321808"/>
-            <a:ext cx="164592" cy="164592"/>
-          </a:xfrm>
-          <a:prstGeom prst="ellipse">
-            <a:avLst/>
-          </a:prstGeom>
-          <a:solidFill>
-            <a:srgbClr val="0B7A75"/>
-          </a:solidFill>
-          <a:ln w="12700">
-            <a:solidFill>
-              <a:srgbClr val="0B7A75"/>
-            </a:solidFill>
-            <a:prstDash val="solid"/>
-          </a:ln>
-        </p:spPr>
-      </p:sp>
-      <p:sp>
-        <p:nvSpPr>
-          <p:cNvPr id="34" name="Text 32"/>
-          <p:cNvSpPr/>
-          <p:nvPr/>
-        </p:nvSpPr>
-        <p:spPr>
-          <a:xfrm>
-            <a:off x="6629400" y="5084064"/>
-            <a:ext cx="4937760" cy="274320"/>
-          </a:xfrm>
-          <a:prstGeom prst="rect">
-            <a:avLst/>
-          </a:prstGeom>
-          <a:noFill/>
-          <a:ln/>
-        </p:spPr>
-        <p:txBody>
-          <a:bodyPr wrap="square" lIns="0" tIns="0" rIns="0" bIns="0" rtlCol="0" anchor="ctr"/>
-          <a:lstStyle/>
-          <a:p>
-            <a:pPr indent="0" marL="0">
-              <a:buNone/>
-            </a:pPr>
-            <a:r>
-              <a:rPr lang="en-US" sz="1000" b="1" dirty="0">
-                <a:solidFill>
-                  <a:srgbClr val="FFFFFF"/>
-                </a:solidFill>
-              </a:rPr>
-              <a:t>Farmacia Tanzilo · Pomigliano d'Arco / Napoli</a:t>
-            </a:r>
-            <a:endParaRPr lang="en-US" sz="1000" dirty="0"/>
-          </a:p>
-        </p:txBody>
-      </p:sp>
-      <p:sp>
-        <p:nvSpPr>
-          <p:cNvPr id="35" name="Text 33"/>
-          <p:cNvSpPr/>
-          <p:nvPr/>
-        </p:nvSpPr>
-        <p:spPr>
-          <a:xfrm>
-            <a:off x="6629400" y="5376672"/>
-            <a:ext cx="4937760" cy="512064"/>
-          </a:xfrm>
-          <a:prstGeom prst="rect">
-            <a:avLst/>
-          </a:prstGeom>
-          <a:noFill/>
-          <a:ln/>
-        </p:spPr>
-        <p:txBody>
-          <a:bodyPr wrap="square" lIns="0" tIns="0" rIns="0" bIns="0" rtlCol="0" anchor="ctr"/>
-          <a:lstStyle/>
-          <a:p>
-            <a:pPr indent="0" marL="0">
-              <a:lnSpc>
-                <a:spcPct val="135000"/>
-              </a:lnSpc>
-              <a:buNone/>
-            </a:pPr>
-            <a:r>
-              <a:rPr lang="en-US" sz="900" dirty="0">
-                <a:solidFill>
-                  <a:srgbClr val="8CB3CC"/>
-                </a:solidFill>
-              </a:rPr>
-              <a:t>Farmacie con delivery medicine e parafarmaci. Tier SMB Pro — validazione verticale healthcare locale.</a:t>
-            </a:r>
-            <a:endParaRPr lang="en-US" sz="900" dirty="0"/>
-          </a:p>
-        </p:txBody>
-      </p:sp>
-      <p:sp>
-        <p:nvSpPr>
-          <p:cNvPr id="36" name="Shape 34"/>
-          <p:cNvSpPr/>
-          <p:nvPr/>
-        </p:nvSpPr>
-        <p:spPr>
-          <a:xfrm>
-            <a:off x="6217920" y="6080760"/>
-            <a:ext cx="5486400" cy="960120"/>
-          </a:xfrm>
-          <a:prstGeom prst="rect">
-            <a:avLst/>
-          </a:prstGeom>
-          <a:solidFill>
-            <a:srgbClr val="0F2535"/>
-          </a:solidFill>
-          <a:ln w="12700">
-            <a:solidFill>
-              <a:srgbClr val="1A3A50"/>
-            </a:solidFill>
-            <a:prstDash val="solid"/>
-          </a:ln>
-        </p:spPr>
-      </p:sp>
-      <p:sp>
-        <p:nvSpPr>
-          <p:cNvPr id="37" name="Shape 35"/>
-          <p:cNvSpPr/>
-          <p:nvPr/>
-        </p:nvSpPr>
-        <p:spPr>
-          <a:xfrm>
-            <a:off x="6355080" y="6373368"/>
-            <a:ext cx="164592" cy="164592"/>
-          </a:xfrm>
-          <a:prstGeom prst="ellipse">
-            <a:avLst/>
-          </a:prstGeom>
-          <a:solidFill>
-            <a:srgbClr val="0B7A75"/>
-          </a:solidFill>
-          <a:ln w="12700">
-            <a:solidFill>
-              <a:srgbClr val="0B7A75"/>
-            </a:solidFill>
-            <a:prstDash val="solid"/>
-          </a:ln>
-        </p:spPr>
-      </p:sp>
-      <p:sp>
-        <p:nvSpPr>
-          <p:cNvPr id="38" name="Text 36"/>
-          <p:cNvSpPr/>
-          <p:nvPr/>
-        </p:nvSpPr>
-        <p:spPr>
-          <a:xfrm>
-            <a:off x="6629400" y="6135624"/>
-            <a:ext cx="4937760" cy="274320"/>
-          </a:xfrm>
-          <a:prstGeom prst="rect">
-            <a:avLst/>
-          </a:prstGeom>
-          <a:noFill/>
-          <a:ln/>
-        </p:spPr>
-        <p:txBody>
-          <a:bodyPr wrap="square" lIns="0" tIns="0" rIns="0" bIns="0" rtlCol="0" anchor="ctr"/>
-          <a:lstStyle/>
-          <a:p>
-            <a:pPr indent="0" marL="0">
-              <a:buNone/>
-            </a:pPr>
-            <a:r>
-              <a:rPr lang="en-US" sz="1000" b="1" dirty="0">
-                <a:solidFill>
-                  <a:srgbClr val="FFFFFF"/>
-                </a:solidFill>
-              </a:rPr>
-              <a:t>NaturaSì Vomero · Napoli  +  PiuMe prodotti casa</a:t>
-            </a:r>
-            <a:endParaRPr lang="en-US" sz="1000" dirty="0"/>
-          </a:p>
-        </p:txBody>
-      </p:sp>
-      <p:sp>
-        <p:nvSpPr>
-          <p:cNvPr id="39" name="Text 37"/>
-          <p:cNvSpPr/>
-          <p:nvPr/>
-        </p:nvSpPr>
-        <p:spPr>
-          <a:xfrm>
-            <a:off x="6629400" y="6428232"/>
-            <a:ext cx="4937760" cy="512064"/>
-          </a:xfrm>
-          <a:prstGeom prst="rect">
-            <a:avLst/>
-          </a:prstGeom>
-          <a:noFill/>
-          <a:ln/>
-        </p:spPr>
-        <p:txBody>
-          <a:bodyPr wrap="square" lIns="0" tIns="0" rIns="0" bIns="0" rtlCol="0" anchor="ctr"/>
-          <a:lstStyle/>
-          <a:p>
-            <a:pPr indent="0" marL="0">
-              <a:lnSpc>
-                <a:spcPct val="135000"/>
-              </a:lnSpc>
-              <a:buNone/>
-            </a:pPr>
-            <a:r>
-              <a:rPr lang="en-US" sz="900" dirty="0">
-                <a:solidFill>
-                  <a:srgbClr val="8CB3CC"/>
-                </a:solidFill>
-              </a:rPr>
-              <a:t>Bio/organico e prodotti per la casa: due verticali distinti, alto valore scontrino, Napoli centro.</a:t>
-            </a:r>
-            <a:endParaRPr lang="en-US" sz="900" dirty="0"/>
-          </a:p>
-        </p:txBody>
-      </p:sp>
-      <p:sp>
-        <p:nvSpPr>
-          <p:cNvPr id="40" name="Shape 38"/>
-          <p:cNvSpPr/>
-          <p:nvPr/>
-        </p:nvSpPr>
-        <p:spPr>
-          <a:xfrm>
-            <a:off x="6217920" y="7132320"/>
-            <a:ext cx="5486400" cy="960120"/>
-          </a:xfrm>
-          <a:prstGeom prst="rect">
-            <a:avLst/>
-          </a:prstGeom>
-          <a:solidFill>
-            <a:srgbClr val="0F2535"/>
-          </a:solidFill>
-          <a:ln w="12700">
-            <a:solidFill>
-              <a:srgbClr val="1A3A50"/>
-            </a:solidFill>
-            <a:prstDash val="solid"/>
-          </a:ln>
-        </p:spPr>
-      </p:sp>
-      <p:sp>
-        <p:nvSpPr>
-          <p:cNvPr id="41" name="Shape 39"/>
-          <p:cNvSpPr/>
-          <p:nvPr/>
-        </p:nvSpPr>
-        <p:spPr>
-          <a:xfrm>
-            <a:off x="6355080" y="7424928"/>
-            <a:ext cx="164592" cy="164592"/>
-          </a:xfrm>
-          <a:prstGeom prst="ellipse">
-            <a:avLst/>
-          </a:prstGeom>
-          <a:solidFill>
-            <a:srgbClr val="F59E0B"/>
-          </a:solidFill>
-          <a:ln w="12700">
-            <a:solidFill>
-              <a:srgbClr val="F59E0B"/>
-            </a:solidFill>
-            <a:prstDash val="solid"/>
-          </a:ln>
-        </p:spPr>
-      </p:sp>
-      <p:sp>
-        <p:nvSpPr>
-          <p:cNvPr id="42" name="Text 40"/>
-          <p:cNvSpPr/>
-          <p:nvPr/>
-        </p:nvSpPr>
-        <p:spPr>
-          <a:xfrm>
-            <a:off x="6629400" y="7187184"/>
-            <a:ext cx="4937760" cy="274320"/>
-          </a:xfrm>
-          <a:prstGeom prst="rect">
-            <a:avLst/>
-          </a:prstGeom>
-          <a:noFill/>
-          <a:ln/>
-        </p:spPr>
-        <p:txBody>
-          <a:bodyPr wrap="square" lIns="0" tIns="0" rIns="0" bIns="0" rtlCol="0" anchor="ctr"/>
-          <a:lstStyle/>
-          <a:p>
-            <a:pPr indent="0" marL="0">
-              <a:buNone/>
-            </a:pPr>
-            <a:r>
-              <a:rPr lang="en-US" sz="1000" b="1" dirty="0">
-                <a:solidFill>
-                  <a:srgbClr val="FFFFFF"/>
-                </a:solidFill>
-              </a:rPr>
-              <a:t>Verifica Twilio in corso (Case #1380112390587406)</a:t>
-            </a:r>
-            <a:endParaRPr lang="en-US" sz="1000" dirty="0"/>
-          </a:p>
-        </p:txBody>
-      </p:sp>
-      <p:sp>
-        <p:nvSpPr>
-          <p:cNvPr id="43" name="Text 41"/>
-          <p:cNvSpPr/>
-          <p:nvPr/>
-        </p:nvSpPr>
-        <p:spPr>
-          <a:xfrm>
-            <a:off x="6629400" y="7479792"/>
-            <a:ext cx="4937760" cy="512064"/>
-          </a:xfrm>
-          <a:prstGeom prst="rect">
-            <a:avLst/>
-          </a:prstGeom>
-          <a:noFill/>
-          <a:ln/>
-        </p:spPr>
-        <p:txBody>
-          <a:bodyPr wrap="square" lIns="0" tIns="0" rIns="0" bIns="0" rtlCol="0" anchor="ctr"/>
-          <a:lstStyle/>
-          <a:p>
-            <a:pPr indent="0" marL="0">
-              <a:lnSpc>
-                <a:spcPct val="135000"/>
-              </a:lnSpc>
-              <a:buNone/>
-            </a:pPr>
-            <a:r>
-              <a:rPr lang="en-US" sz="900" dirty="0">
-                <a:solidFill>
-                  <a:srgbClr val="8CB3CC"/>
-                </a:solidFill>
-              </a:rPr>
-              <a:t>Documentazione inviata. Fallback alternativo pronto. WhatsApp Business API operativa entro 15gg.</a:t>
-            </a:r>
-            <a:endParaRPr lang="en-US" sz="900" dirty="0"/>
-          </a:p>
-        </p:txBody>
-      </p:sp>
-      <p:sp>
-        <p:nvSpPr>
-          <p:cNvPr id="44" name="Shape 42"/>
-          <p:cNvSpPr/>
-          <p:nvPr/>
-        </p:nvSpPr>
-        <p:spPr>
-          <a:xfrm>
-            <a:off x="6217920" y="8183880"/>
-            <a:ext cx="5486400" cy="960120"/>
-          </a:xfrm>
-          <a:prstGeom prst="rect">
-            <a:avLst/>
-          </a:prstGeom>
-          <a:solidFill>
-            <a:srgbClr val="0F2535"/>
-          </a:solidFill>
-          <a:ln w="12700">
-            <a:solidFill>
-              <a:srgbClr val="1A3A50"/>
-            </a:solidFill>
-            <a:prstDash val="solid"/>
-          </a:ln>
-        </p:spPr>
-      </p:sp>
-      <p:sp>
-        <p:nvSpPr>
-          <p:cNvPr id="45" name="Shape 43"/>
-          <p:cNvSpPr/>
-          <p:nvPr/>
-        </p:nvSpPr>
-        <p:spPr>
-          <a:xfrm>
-            <a:off x="6355080" y="8476488"/>
-            <a:ext cx="164592" cy="164592"/>
-          </a:xfrm>
-          <a:prstGeom prst="ellipse">
-            <a:avLst/>
-          </a:prstGeom>
-          <a:solidFill>
-            <a:srgbClr val="0B7A75"/>
-          </a:solidFill>
-          <a:ln w="12700">
-            <a:solidFill>
-              <a:srgbClr val="0B7A75"/>
-            </a:solidFill>
-            <a:prstDash val="solid"/>
-          </a:ln>
-        </p:spPr>
-      </p:sp>
-      <p:sp>
-        <p:nvSpPr>
-          <p:cNvPr id="46" name="Text 44"/>
-          <p:cNvSpPr/>
-          <p:nvPr/>
-        </p:nvSpPr>
-        <p:spPr>
-          <a:xfrm>
-            <a:off x="6629400" y="8238744"/>
-            <a:ext cx="4937760" cy="274320"/>
-          </a:xfrm>
-          <a:prstGeom prst="rect">
-            <a:avLst/>
-          </a:prstGeom>
-          <a:noFill/>
-          <a:ln/>
-        </p:spPr>
-        <p:txBody>
-          <a:bodyPr wrap="square" lIns="0" tIns="0" rIns="0" bIns="0" rtlCol="0" anchor="ctr"/>
-          <a:lstStyle/>
-          <a:p>
-            <a:pPr indent="0" marL="0">
-              <a:buNone/>
-            </a:pPr>
-            <a:r>
-              <a:rPr lang="en-US" sz="1000" b="1" dirty="0">
-                <a:solidFill>
-                  <a:srgbClr val="FFFFFF"/>
-                </a:solidFill>
-              </a:rPr>
-              <a:t>GitHub pubblico con pitch deck live</a:t>
-            </a:r>
-            <a:endParaRPr lang="en-US" sz="1000" dirty="0"/>
-          </a:p>
-        </p:txBody>
-      </p:sp>
-      <p:sp>
-        <p:nvSpPr>
-          <p:cNvPr id="47" name="Text 45"/>
-          <p:cNvSpPr/>
-          <p:nvPr/>
-        </p:nvSpPr>
-        <p:spPr>
-          <a:xfrm>
-            <a:off x="6629400" y="8531352"/>
-            <a:ext cx="4937760" cy="512064"/>
-          </a:xfrm>
-          <a:prstGeom prst="rect">
-            <a:avLst/>
-          </a:prstGeom>
-          <a:noFill/>
-          <a:ln/>
-        </p:spPr>
-        <p:txBody>
-          <a:bodyPr wrap="square" lIns="0" tIns="0" rIns="0" bIns="0" rtlCol="0" anchor="ctr"/>
-          <a:lstStyle/>
-          <a:p>
-            <a:pPr indent="0" marL="0">
-              <a:lnSpc>
-                <a:spcPct val="135000"/>
-              </a:lnSpc>
-              <a:buNone/>
-            </a:pPr>
-            <a:r>
-              <a:rPr lang="en-US" sz="900" dirty="0">
-                <a:solidFill>
-                  <a:srgbClr val="8CB3CC"/>
-                </a:solidFill>
-              </a:rPr>
-              <a:t>github.com/creamoj-ai/dloop-pitch-deck — due diligence tecnica aperta. GitHub Pages attivo.</a:t>
-            </a:r>
-            <a:endParaRPr lang="en-US" sz="900" dirty="0"/>
-          </a:p>
-        </p:txBody>
-      </p:sp>
-      <p:sp>
-        <p:nvSpPr>
-          <p:cNvPr id="48" name="Text 46"/>
+          <p:cNvPr id="36" name="Text 34"/>
           <p:cNvSpPr/>
           <p:nvPr/>
         </p:nvSpPr>

</xml_diff>

<commit_message>
✅ Fonti dati finalmente visibili — v4.3
- Mercato: fonti in piccolo DENTRO ogni card KPI
  (Statista/Casaleggio · ISTAT/CCIAA Napoli · stima interna Dloop)
- Competitor: fonti sotto il titolo della slide
  (Capterra IT 2025 · G2.com · siti ufficiali · pricing pubblico)
</commit_message>
<xml_diff>
--- a/02-INVESTOR-PRESENTATIONS/DLOOP_Pitch_Deck_2026.pptx
+++ b/02-INVESTOR-PRESENTATIONS/DLOOP_Pitch_Deck_2026.pptx
@@ -7407,7 +7407,7 @@
         <p:spPr>
           <a:xfrm>
             <a:off x="457200" y="3520440"/>
-            <a:ext cx="3520440" cy="274320"/>
+            <a:ext cx="3520440" cy="228600"/>
           </a:xfrm>
           <a:prstGeom prst="rect">
             <a:avLst/>
@@ -7436,7 +7436,43 @@
       </p:sp>
       <p:sp>
         <p:nvSpPr>
-          <p:cNvPr id="9" name="Shape 7"/>
+          <p:cNvPr id="9" name="Text 7"/>
+          <p:cNvSpPr/>
+          <p:nvPr/>
+        </p:nvSpPr>
+        <p:spPr>
+          <a:xfrm>
+            <a:off x="548640" y="3822192"/>
+            <a:ext cx="3337560" cy="182880"/>
+          </a:xfrm>
+          <a:prstGeom prst="rect">
+            <a:avLst/>
+          </a:prstGeom>
+          <a:noFill/>
+          <a:ln/>
+        </p:spPr>
+        <p:txBody>
+          <a:bodyPr wrap="square" lIns="0" tIns="0" rIns="0" bIns="0" rtlCol="0" anchor="ctr"/>
+          <a:lstStyle/>
+          <a:p>
+            <a:pPr algn="ctr" indent="0" marL="0">
+              <a:buNone/>
+            </a:pPr>
+            <a:r>
+              <a:rPr lang="en-US" sz="750" dirty="0">
+                <a:solidFill>
+                  <a:srgbClr val="4A7A8A"/>
+                </a:solidFill>
+              </a:rPr>
+              <a:t>Fonte: Statista / Casaleggio Assoc. 2025</a:t>
+            </a:r>
+            <a:endParaRPr lang="en-US" sz="750" dirty="0"/>
+          </a:p>
+        </p:txBody>
+      </p:sp>
+      <p:sp>
+        <p:nvSpPr>
+          <p:cNvPr id="10" name="Shape 8"/>
           <p:cNvSpPr/>
           <p:nvPr/>
         </p:nvSpPr>
@@ -7461,7 +7497,7 @@
       </p:sp>
       <p:sp>
         <p:nvSpPr>
-          <p:cNvPr id="10" name="Text 8"/>
+          <p:cNvPr id="11" name="Text 9"/>
           <p:cNvSpPr/>
           <p:nvPr/>
         </p:nvSpPr>
@@ -7500,7 +7536,7 @@
       </p:sp>
       <p:sp>
         <p:nvSpPr>
-          <p:cNvPr id="11" name="Text 9"/>
+          <p:cNvPr id="12" name="Text 10"/>
           <p:cNvSpPr/>
           <p:nvPr/>
         </p:nvSpPr>
@@ -7556,7 +7592,7 @@
       </p:sp>
       <p:sp>
         <p:nvSpPr>
-          <p:cNvPr id="12" name="Shape 10"/>
+          <p:cNvPr id="13" name="Shape 11"/>
           <p:cNvSpPr/>
           <p:nvPr/>
         </p:nvSpPr>
@@ -7581,14 +7617,14 @@
       </p:sp>
       <p:sp>
         <p:nvSpPr>
-          <p:cNvPr id="13" name="Text 11"/>
+          <p:cNvPr id="14" name="Text 12"/>
           <p:cNvSpPr/>
           <p:nvPr/>
         </p:nvSpPr>
         <p:spPr>
           <a:xfrm>
             <a:off x="4297680" y="3520440"/>
-            <a:ext cx="3520440" cy="274320"/>
+            <a:ext cx="3520440" cy="228600"/>
           </a:xfrm>
           <a:prstGeom prst="rect">
             <a:avLst/>
@@ -7617,7 +7653,43 @@
       </p:sp>
       <p:sp>
         <p:nvSpPr>
-          <p:cNvPr id="14" name="Shape 12"/>
+          <p:cNvPr id="15" name="Text 13"/>
+          <p:cNvSpPr/>
+          <p:nvPr/>
+        </p:nvSpPr>
+        <p:spPr>
+          <a:xfrm>
+            <a:off x="4389120" y="3822192"/>
+            <a:ext cx="3337560" cy="182880"/>
+          </a:xfrm>
+          <a:prstGeom prst="rect">
+            <a:avLst/>
+          </a:prstGeom>
+          <a:noFill/>
+          <a:ln/>
+        </p:spPr>
+        <p:txBody>
+          <a:bodyPr wrap="square" lIns="0" tIns="0" rIns="0" bIns="0" rtlCol="0" anchor="ctr"/>
+          <a:lstStyle/>
+          <a:p>
+            <a:pPr algn="ctr" indent="0" marL="0">
+              <a:buNone/>
+            </a:pPr>
+            <a:r>
+              <a:rPr lang="en-US" sz="750" dirty="0">
+                <a:solidFill>
+                  <a:srgbClr val="4A7A8A"/>
+                </a:solidFill>
+              </a:rPr>
+              <a:t>Fonte: ISTAT / CCIAA Napoli 2025</a:t>
+            </a:r>
+            <a:endParaRPr lang="en-US" sz="750" dirty="0"/>
+          </a:p>
+        </p:txBody>
+      </p:sp>
+      <p:sp>
+        <p:nvSpPr>
+          <p:cNvPr id="16" name="Shape 14"/>
           <p:cNvSpPr/>
           <p:nvPr/>
         </p:nvSpPr>
@@ -7642,7 +7714,7 @@
       </p:sp>
       <p:sp>
         <p:nvSpPr>
-          <p:cNvPr id="15" name="Text 13"/>
+          <p:cNvPr id="17" name="Text 15"/>
           <p:cNvSpPr/>
           <p:nvPr/>
         </p:nvSpPr>
@@ -7681,7 +7753,7 @@
       </p:sp>
       <p:sp>
         <p:nvSpPr>
-          <p:cNvPr id="16" name="Text 14"/>
+          <p:cNvPr id="18" name="Text 16"/>
           <p:cNvSpPr/>
           <p:nvPr/>
         </p:nvSpPr>
@@ -7737,7 +7809,7 @@
       </p:sp>
       <p:sp>
         <p:nvSpPr>
-          <p:cNvPr id="17" name="Shape 15"/>
+          <p:cNvPr id="19" name="Shape 17"/>
           <p:cNvSpPr/>
           <p:nvPr/>
         </p:nvSpPr>
@@ -7762,14 +7834,14 @@
       </p:sp>
       <p:sp>
         <p:nvSpPr>
-          <p:cNvPr id="18" name="Text 16"/>
+          <p:cNvPr id="20" name="Text 18"/>
           <p:cNvSpPr/>
           <p:nvPr/>
         </p:nvSpPr>
         <p:spPr>
           <a:xfrm>
             <a:off x="8138160" y="3520440"/>
-            <a:ext cx="3520440" cy="274320"/>
+            <a:ext cx="3520440" cy="228600"/>
           </a:xfrm>
           <a:prstGeom prst="rect">
             <a:avLst/>
@@ -7798,14 +7870,50 @@
       </p:sp>
       <p:sp>
         <p:nvSpPr>
-          <p:cNvPr id="19" name="Shape 17"/>
-          <p:cNvSpPr/>
-          <p:nvPr/>
-        </p:nvSpPr>
-        <p:spPr>
-          <a:xfrm>
-            <a:off x="457200" y="4572000"/>
-            <a:ext cx="5577840" cy="1234440"/>
+          <p:cNvPr id="21" name="Text 19"/>
+          <p:cNvSpPr/>
+          <p:nvPr/>
+        </p:nvSpPr>
+        <p:spPr>
+          <a:xfrm>
+            <a:off x="8229600" y="3822192"/>
+            <a:ext cx="3337560" cy="182880"/>
+          </a:xfrm>
+          <a:prstGeom prst="rect">
+            <a:avLst/>
+          </a:prstGeom>
+          <a:noFill/>
+          <a:ln/>
+        </p:spPr>
+        <p:txBody>
+          <a:bodyPr wrap="square" lIns="0" tIns="0" rIns="0" bIns="0" rtlCol="0" anchor="ctr"/>
+          <a:lstStyle/>
+          <a:p>
+            <a:pPr algn="ctr" indent="0" marL="0">
+              <a:buNone/>
+            </a:pPr>
+            <a:r>
+              <a:rPr lang="en-US" sz="750" dirty="0">
+                <a:solidFill>
+                  <a:srgbClr val="4A7A8A"/>
+                </a:solidFill>
+              </a:rPr>
+              <a:t>Fonte: stima interna Dloop su dati CCIAA</a:t>
+            </a:r>
+            <a:endParaRPr lang="en-US" sz="750" dirty="0"/>
+          </a:p>
+        </p:txBody>
+      </p:sp>
+      <p:sp>
+        <p:nvSpPr>
+          <p:cNvPr id="22" name="Shape 20"/>
+          <p:cNvSpPr/>
+          <p:nvPr/>
+        </p:nvSpPr>
+        <p:spPr>
+          <a:xfrm>
+            <a:off x="457200" y="4434840"/>
+            <a:ext cx="5577840" cy="868680"/>
           </a:xfrm>
           <a:prstGeom prst="rect">
             <a:avLst/>
@@ -7823,14 +7931,14 @@
       </p:sp>
       <p:sp>
         <p:nvSpPr>
-          <p:cNvPr id="20" name="Text 18"/>
-          <p:cNvSpPr/>
-          <p:nvPr/>
-        </p:nvSpPr>
-        <p:spPr>
-          <a:xfrm>
-            <a:off x="640080" y="4663440"/>
-            <a:ext cx="5212080" cy="256032"/>
+          <p:cNvPr id="23" name="Text 21"/>
+          <p:cNvSpPr/>
+          <p:nvPr/>
+        </p:nvSpPr>
+        <p:spPr>
+          <a:xfrm>
+            <a:off x="640080" y="4480560"/>
+            <a:ext cx="5212080" cy="237744"/>
           </a:xfrm>
           <a:prstGeom prst="rect">
             <a:avLst/>
@@ -7859,7 +7967,7 @@
       </p:sp>
       <p:sp>
         <p:nvSpPr>
-          <p:cNvPr id="21" name="Text 19"/>
+          <p:cNvPr id="24" name="Text 22"/>
           <p:cNvSpPr/>
           <p:nvPr/>
         </p:nvSpPr>
@@ -7898,14 +8006,14 @@
       </p:sp>
       <p:sp>
         <p:nvSpPr>
-          <p:cNvPr id="22" name="Shape 20"/>
-          <p:cNvSpPr/>
-          <p:nvPr/>
-        </p:nvSpPr>
-        <p:spPr>
-          <a:xfrm>
-            <a:off x="6309360" y="4572000"/>
-            <a:ext cx="5349240" cy="1234440"/>
+          <p:cNvPr id="25" name="Shape 23"/>
+          <p:cNvSpPr/>
+          <p:nvPr/>
+        </p:nvSpPr>
+        <p:spPr>
+          <a:xfrm>
+            <a:off x="6309360" y="4434840"/>
+            <a:ext cx="5349240" cy="868680"/>
           </a:xfrm>
           <a:prstGeom prst="rect">
             <a:avLst/>
@@ -7923,14 +8031,14 @@
       </p:sp>
       <p:sp>
         <p:nvSpPr>
-          <p:cNvPr id="23" name="Text 21"/>
-          <p:cNvSpPr/>
-          <p:nvPr/>
-        </p:nvSpPr>
-        <p:spPr>
-          <a:xfrm>
-            <a:off x="6492240" y="4663440"/>
-            <a:ext cx="4937760" cy="256032"/>
+          <p:cNvPr id="26" name="Text 24"/>
+          <p:cNvSpPr/>
+          <p:nvPr/>
+        </p:nvSpPr>
+        <p:spPr>
+          <a:xfrm>
+            <a:off x="6492240" y="4480560"/>
+            <a:ext cx="4937760" cy="237744"/>
           </a:xfrm>
           <a:prstGeom prst="rect">
             <a:avLst/>
@@ -7959,14 +8067,14 @@
       </p:sp>
       <p:sp>
         <p:nvSpPr>
-          <p:cNvPr id="24" name="Text 22"/>
-          <p:cNvSpPr/>
-          <p:nvPr/>
-        </p:nvSpPr>
-        <p:spPr>
-          <a:xfrm>
-            <a:off x="6492240" y="4956048"/>
-            <a:ext cx="4937760" cy="731520"/>
+          <p:cNvPr id="27" name="Text 25"/>
+          <p:cNvSpPr/>
+          <p:nvPr/>
+        </p:nvSpPr>
+        <p:spPr>
+          <a:xfrm>
+            <a:off x="6492240" y="4754880"/>
+            <a:ext cx="4937760" cy="502920"/>
           </a:xfrm>
           <a:prstGeom prst="rect">
             <a:avLst/>
@@ -7980,7 +8088,7 @@
           <a:p>
             <a:pPr indent="0" marL="0">
               <a:lnSpc>
-                <a:spcPct val="140000"/>
+                <a:spcPct val="130000"/>
               </a:lnSpc>
               <a:buNone/>
             </a:pPr>
@@ -7998,7 +8106,7 @@
       </p:sp>
       <p:sp>
         <p:nvSpPr>
-          <p:cNvPr id="25" name="Text 23"/>
+          <p:cNvPr id="28" name="Text 26"/>
           <p:cNvSpPr/>
           <p:nvPr/>
         </p:nvSpPr>
@@ -8108,8 +8216,8 @@
         </p:nvSpPr>
         <p:spPr>
           <a:xfrm>
-            <a:off x="457200" y="640080"/>
-            <a:ext cx="8229600" cy="1005840"/>
+            <a:off x="457200" y="621792"/>
+            <a:ext cx="9144000" cy="594360"/>
           </a:xfrm>
           <a:prstGeom prst="rect">
             <a:avLst/>
@@ -8122,13 +8230,10 @@
           <a:lstStyle/>
           <a:p>
             <a:pPr indent="0" marL="0">
-              <a:lnSpc>
-                <a:spcPct val="110000"/>
-              </a:lnSpc>
-              <a:buNone/>
-            </a:pPr>
-            <a:r>
-              <a:rPr lang="en-US" sz="3400" b="1" dirty="0">
+              <a:buNone/>
+            </a:pPr>
+            <a:r>
+              <a:rPr lang="en-US" sz="3000" b="1" dirty="0">
                 <a:solidFill>
                   <a:srgbClr val="FFFFFF"/>
                 </a:solidFill>
@@ -8136,35 +8241,51 @@
                 <a:ea typeface="Georgia" pitchFamily="34" charset="-122"/>
                 <a:cs typeface="Georgia" pitchFamily="34" charset="-120"/>
               </a:rPr>
-              <a:t>Nessun competitor ha</a:t>
-            </a:r>
-            <a:endParaRPr lang="en-US" sz="3400" dirty="0"/>
-          </a:p>
+              <a:t>Nessun competitor ha il posizionamento di Dloop</a:t>
+            </a:r>
+            <a:endParaRPr lang="en-US" sz="3000" dirty="0"/>
+          </a:p>
+        </p:txBody>
+      </p:sp>
+      <p:sp>
+        <p:nvSpPr>
+          <p:cNvPr id="4" name="Text 2"/>
+          <p:cNvSpPr/>
+          <p:nvPr/>
+        </p:nvSpPr>
+        <p:spPr>
+          <a:xfrm>
+            <a:off x="457200" y="1261872"/>
+            <a:ext cx="11247120" cy="228600"/>
+          </a:xfrm>
+          <a:prstGeom prst="rect">
+            <a:avLst/>
+          </a:prstGeom>
+          <a:noFill/>
+          <a:ln/>
+        </p:spPr>
+        <p:txBody>
+          <a:bodyPr wrap="square" lIns="0" tIns="0" rIns="0" bIns="0" rtlCol="0" anchor="ctr"/>
+          <a:lstStyle/>
           <a:p>
             <a:pPr indent="0" marL="0">
-              <a:lnSpc>
-                <a:spcPct val="110000"/>
-              </a:lnSpc>
-              <a:buNone/>
-            </a:pPr>
-            <a:r>
-              <a:rPr lang="en-US" sz="3400" b="1" dirty="0">
-                <a:solidFill>
-                  <a:srgbClr val="FFFFFF"/>
-                </a:solidFill>
-                <a:latin typeface="Georgia" pitchFamily="34" charset="0"/>
-                <a:ea typeface="Georgia" pitchFamily="34" charset="-122"/>
-                <a:cs typeface="Georgia" pitchFamily="34" charset="-120"/>
-              </a:rPr>
-              <a:t>il posizionamento di Dloop</a:t>
-            </a:r>
-            <a:endParaRPr lang="en-US" sz="3400" dirty="0"/>
-          </a:p>
-        </p:txBody>
-      </p:sp>
-      <p:sp>
-        <p:nvSpPr>
-          <p:cNvPr id="4" name="Shape 2"/>
+              <a:buNone/>
+            </a:pPr>
+            <a:r>
+              <a:rPr lang="en-US" sz="800" dirty="0">
+                <a:solidFill>
+                  <a:srgbClr val="4A7A8A"/>
+                </a:solidFill>
+              </a:rPr>
+              <a:t>Fonti: Capterra IT 2025  ·  G2.com  ·  siti ufficiali Onfleet / Tookan / LogiNext  ·  pricing pubblico Glovo / Deliveroo / Alfonsino / Uber Eats</a:t>
+            </a:r>
+            <a:endParaRPr lang="en-US" sz="800" dirty="0"/>
+          </a:p>
+        </p:txBody>
+      </p:sp>
+      <p:sp>
+        <p:nvSpPr>
+          <p:cNvPr id="5" name="Shape 3"/>
           <p:cNvSpPr/>
           <p:nvPr/>
         </p:nvSpPr>
@@ -8189,7 +8310,7 @@
       </p:sp>
       <p:sp>
         <p:nvSpPr>
-          <p:cNvPr id="5" name="Text 3"/>
+          <p:cNvPr id="6" name="Text 4"/>
           <p:cNvSpPr/>
           <p:nvPr/>
         </p:nvSpPr>
@@ -8228,7 +8349,7 @@
       </p:sp>
       <p:sp>
         <p:nvSpPr>
-          <p:cNvPr id="6" name="Shape 4"/>
+          <p:cNvPr id="7" name="Shape 5"/>
           <p:cNvSpPr/>
           <p:nvPr/>
         </p:nvSpPr>
@@ -8253,7 +8374,7 @@
       </p:sp>
       <p:sp>
         <p:nvSpPr>
-          <p:cNvPr id="7" name="Text 5"/>
+          <p:cNvPr id="8" name="Text 6"/>
           <p:cNvSpPr/>
           <p:nvPr/>
         </p:nvSpPr>
@@ -8292,7 +8413,7 @@
       </p:sp>
       <p:sp>
         <p:nvSpPr>
-          <p:cNvPr id="8" name="Shape 6"/>
+          <p:cNvPr id="9" name="Shape 7"/>
           <p:cNvSpPr/>
           <p:nvPr/>
         </p:nvSpPr>
@@ -8317,7 +8438,7 @@
       </p:sp>
       <p:sp>
         <p:nvSpPr>
-          <p:cNvPr id="9" name="Text 7"/>
+          <p:cNvPr id="10" name="Text 8"/>
           <p:cNvSpPr/>
           <p:nvPr/>
         </p:nvSpPr>
@@ -8373,7 +8494,7 @@
       </p:sp>
       <p:sp>
         <p:nvSpPr>
-          <p:cNvPr id="10" name="Shape 8"/>
+          <p:cNvPr id="11" name="Shape 9"/>
           <p:cNvSpPr/>
           <p:nvPr/>
         </p:nvSpPr>
@@ -8398,7 +8519,7 @@
       </p:sp>
       <p:sp>
         <p:nvSpPr>
-          <p:cNvPr id="11" name="Text 9"/>
+          <p:cNvPr id="12" name="Text 10"/>
           <p:cNvSpPr/>
           <p:nvPr/>
         </p:nvSpPr>
@@ -8454,7 +8575,7 @@
       </p:sp>
       <p:sp>
         <p:nvSpPr>
-          <p:cNvPr id="12" name="Shape 10"/>
+          <p:cNvPr id="13" name="Shape 11"/>
           <p:cNvSpPr/>
           <p:nvPr/>
         </p:nvSpPr>
@@ -8479,7 +8600,7 @@
       </p:sp>
       <p:sp>
         <p:nvSpPr>
-          <p:cNvPr id="13" name="Text 11"/>
+          <p:cNvPr id="14" name="Text 12"/>
           <p:cNvSpPr/>
           <p:nvPr/>
         </p:nvSpPr>
@@ -8535,7 +8656,7 @@
       </p:sp>
       <p:sp>
         <p:nvSpPr>
-          <p:cNvPr id="14" name="Shape 12"/>
+          <p:cNvPr id="15" name="Shape 13"/>
           <p:cNvSpPr/>
           <p:nvPr/>
         </p:nvSpPr>
@@ -8560,7 +8681,7 @@
       </p:sp>
       <p:sp>
         <p:nvSpPr>
-          <p:cNvPr id="15" name="Text 13"/>
+          <p:cNvPr id="16" name="Text 14"/>
           <p:cNvSpPr/>
           <p:nvPr/>
         </p:nvSpPr>
@@ -8616,7 +8737,7 @@
       </p:sp>
       <p:sp>
         <p:nvSpPr>
-          <p:cNvPr id="16" name="Shape 14"/>
+          <p:cNvPr id="17" name="Shape 15"/>
           <p:cNvSpPr/>
           <p:nvPr/>
         </p:nvSpPr>
@@ -8641,7 +8762,7 @@
       </p:sp>
       <p:sp>
         <p:nvSpPr>
-          <p:cNvPr id="17" name="Text 15"/>
+          <p:cNvPr id="18" name="Text 16"/>
           <p:cNvSpPr/>
           <p:nvPr/>
         </p:nvSpPr>
@@ -8697,7 +8818,7 @@
       </p:sp>
       <p:sp>
         <p:nvSpPr>
-          <p:cNvPr id="18" name="Shape 16"/>
+          <p:cNvPr id="19" name="Shape 17"/>
           <p:cNvSpPr/>
           <p:nvPr/>
         </p:nvSpPr>
@@ -8722,7 +8843,7 @@
       </p:sp>
       <p:sp>
         <p:nvSpPr>
-          <p:cNvPr id="19" name="Shape 17"/>
+          <p:cNvPr id="20" name="Shape 18"/>
           <p:cNvSpPr/>
           <p:nvPr/>
         </p:nvSpPr>
@@ -8747,7 +8868,7 @@
       </p:sp>
       <p:sp>
         <p:nvSpPr>
-          <p:cNvPr id="20" name="Text 18"/>
+          <p:cNvPr id="21" name="Text 19"/>
           <p:cNvSpPr/>
           <p:nvPr/>
         </p:nvSpPr>
@@ -8783,7 +8904,7 @@
       </p:sp>
       <p:sp>
         <p:nvSpPr>
-          <p:cNvPr id="21" name="Shape 19"/>
+          <p:cNvPr id="22" name="Shape 20"/>
           <p:cNvSpPr/>
           <p:nvPr/>
         </p:nvSpPr>
@@ -8808,7 +8929,7 @@
       </p:sp>
       <p:sp>
         <p:nvSpPr>
-          <p:cNvPr id="22" name="Text 20"/>
+          <p:cNvPr id="23" name="Text 21"/>
           <p:cNvSpPr/>
           <p:nvPr/>
         </p:nvSpPr>
@@ -8844,7 +8965,7 @@
       </p:sp>
       <p:sp>
         <p:nvSpPr>
-          <p:cNvPr id="23" name="Shape 21"/>
+          <p:cNvPr id="24" name="Shape 22"/>
           <p:cNvSpPr/>
           <p:nvPr/>
         </p:nvSpPr>
@@ -8869,7 +8990,7 @@
       </p:sp>
       <p:sp>
         <p:nvSpPr>
-          <p:cNvPr id="24" name="Text 22"/>
+          <p:cNvPr id="25" name="Text 23"/>
           <p:cNvSpPr/>
           <p:nvPr/>
         </p:nvSpPr>
@@ -8905,7 +9026,7 @@
       </p:sp>
       <p:sp>
         <p:nvSpPr>
-          <p:cNvPr id="25" name="Shape 23"/>
+          <p:cNvPr id="26" name="Shape 24"/>
           <p:cNvSpPr/>
           <p:nvPr/>
         </p:nvSpPr>
@@ -8930,7 +9051,7 @@
       </p:sp>
       <p:sp>
         <p:nvSpPr>
-          <p:cNvPr id="26" name="Text 24"/>
+          <p:cNvPr id="27" name="Text 25"/>
           <p:cNvSpPr/>
           <p:nvPr/>
         </p:nvSpPr>
@@ -8966,7 +9087,7 @@
       </p:sp>
       <p:sp>
         <p:nvSpPr>
-          <p:cNvPr id="27" name="Shape 25"/>
+          <p:cNvPr id="28" name="Shape 26"/>
           <p:cNvSpPr/>
           <p:nvPr/>
         </p:nvSpPr>
@@ -8991,7 +9112,7 @@
       </p:sp>
       <p:sp>
         <p:nvSpPr>
-          <p:cNvPr id="28" name="Text 26"/>
+          <p:cNvPr id="29" name="Text 27"/>
           <p:cNvSpPr/>
           <p:nvPr/>
         </p:nvSpPr>
@@ -9027,7 +9148,7 @@
       </p:sp>
       <p:sp>
         <p:nvSpPr>
-          <p:cNvPr id="29" name="Shape 27"/>
+          <p:cNvPr id="30" name="Shape 28"/>
           <p:cNvSpPr/>
           <p:nvPr/>
         </p:nvSpPr>
@@ -9052,7 +9173,7 @@
       </p:sp>
       <p:sp>
         <p:nvSpPr>
-          <p:cNvPr id="30" name="Text 28"/>
+          <p:cNvPr id="31" name="Text 29"/>
           <p:cNvSpPr/>
           <p:nvPr/>
         </p:nvSpPr>
@@ -9088,7 +9209,7 @@
       </p:sp>
       <p:sp>
         <p:nvSpPr>
-          <p:cNvPr id="31" name="Shape 29"/>
+          <p:cNvPr id="32" name="Shape 30"/>
           <p:cNvSpPr/>
           <p:nvPr/>
         </p:nvSpPr>
@@ -9113,7 +9234,7 @@
       </p:sp>
       <p:sp>
         <p:nvSpPr>
-          <p:cNvPr id="32" name="Text 30"/>
+          <p:cNvPr id="33" name="Text 31"/>
           <p:cNvSpPr/>
           <p:nvPr/>
         </p:nvSpPr>
@@ -9149,7 +9270,7 @@
       </p:sp>
       <p:sp>
         <p:nvSpPr>
-          <p:cNvPr id="33" name="Shape 31"/>
+          <p:cNvPr id="34" name="Shape 32"/>
           <p:cNvSpPr/>
           <p:nvPr/>
         </p:nvSpPr>
@@ -9174,7 +9295,7 @@
       </p:sp>
       <p:sp>
         <p:nvSpPr>
-          <p:cNvPr id="34" name="Text 32"/>
+          <p:cNvPr id="35" name="Text 33"/>
           <p:cNvSpPr/>
           <p:nvPr/>
         </p:nvSpPr>
@@ -9210,7 +9331,7 @@
       </p:sp>
       <p:sp>
         <p:nvSpPr>
-          <p:cNvPr id="35" name="Shape 33"/>
+          <p:cNvPr id="36" name="Shape 34"/>
           <p:cNvSpPr/>
           <p:nvPr/>
         </p:nvSpPr>
@@ -9235,7 +9356,7 @@
       </p:sp>
       <p:sp>
         <p:nvSpPr>
-          <p:cNvPr id="36" name="Text 34"/>
+          <p:cNvPr id="37" name="Text 35"/>
           <p:cNvSpPr/>
           <p:nvPr/>
         </p:nvSpPr>
@@ -9271,7 +9392,7 @@
       </p:sp>
       <p:sp>
         <p:nvSpPr>
-          <p:cNvPr id="37" name="Shape 35"/>
+          <p:cNvPr id="38" name="Shape 36"/>
           <p:cNvSpPr/>
           <p:nvPr/>
         </p:nvSpPr>
@@ -9296,7 +9417,7 @@
       </p:sp>
       <p:sp>
         <p:nvSpPr>
-          <p:cNvPr id="38" name="Text 36"/>
+          <p:cNvPr id="39" name="Text 37"/>
           <p:cNvSpPr/>
           <p:nvPr/>
         </p:nvSpPr>
@@ -9332,7 +9453,7 @@
       </p:sp>
       <p:sp>
         <p:nvSpPr>
-          <p:cNvPr id="39" name="Shape 37"/>
+          <p:cNvPr id="40" name="Shape 38"/>
           <p:cNvSpPr/>
           <p:nvPr/>
         </p:nvSpPr>
@@ -9357,7 +9478,7 @@
       </p:sp>
       <p:sp>
         <p:nvSpPr>
-          <p:cNvPr id="40" name="Text 38"/>
+          <p:cNvPr id="41" name="Text 39"/>
           <p:cNvSpPr/>
           <p:nvPr/>
         </p:nvSpPr>
@@ -9393,7 +9514,7 @@
       </p:sp>
       <p:sp>
         <p:nvSpPr>
-          <p:cNvPr id="41" name="Shape 39"/>
+          <p:cNvPr id="42" name="Shape 40"/>
           <p:cNvSpPr/>
           <p:nvPr/>
         </p:nvSpPr>
@@ -9418,7 +9539,7 @@
       </p:sp>
       <p:sp>
         <p:nvSpPr>
-          <p:cNvPr id="42" name="Text 40"/>
+          <p:cNvPr id="43" name="Text 41"/>
           <p:cNvSpPr/>
           <p:nvPr/>
         </p:nvSpPr>
@@ -9454,7 +9575,7 @@
       </p:sp>
       <p:sp>
         <p:nvSpPr>
-          <p:cNvPr id="43" name="Shape 41"/>
+          <p:cNvPr id="44" name="Shape 42"/>
           <p:cNvSpPr/>
           <p:nvPr/>
         </p:nvSpPr>
@@ -9479,7 +9600,7 @@
       </p:sp>
       <p:sp>
         <p:nvSpPr>
-          <p:cNvPr id="44" name="Text 42"/>
+          <p:cNvPr id="45" name="Text 43"/>
           <p:cNvSpPr/>
           <p:nvPr/>
         </p:nvSpPr>
@@ -9515,7 +9636,7 @@
       </p:sp>
       <p:sp>
         <p:nvSpPr>
-          <p:cNvPr id="45" name="Shape 43"/>
+          <p:cNvPr id="46" name="Shape 44"/>
           <p:cNvSpPr/>
           <p:nvPr/>
         </p:nvSpPr>
@@ -9540,7 +9661,7 @@
       </p:sp>
       <p:sp>
         <p:nvSpPr>
-          <p:cNvPr id="46" name="Text 44"/>
+          <p:cNvPr id="47" name="Text 45"/>
           <p:cNvSpPr/>
           <p:nvPr/>
         </p:nvSpPr>
@@ -9576,7 +9697,7 @@
       </p:sp>
       <p:sp>
         <p:nvSpPr>
-          <p:cNvPr id="47" name="Shape 45"/>
+          <p:cNvPr id="48" name="Shape 46"/>
           <p:cNvSpPr/>
           <p:nvPr/>
         </p:nvSpPr>
@@ -9601,7 +9722,7 @@
       </p:sp>
       <p:sp>
         <p:nvSpPr>
-          <p:cNvPr id="48" name="Text 46"/>
+          <p:cNvPr id="49" name="Text 47"/>
           <p:cNvSpPr/>
           <p:nvPr/>
         </p:nvSpPr>
@@ -9637,7 +9758,7 @@
       </p:sp>
       <p:sp>
         <p:nvSpPr>
-          <p:cNvPr id="49" name="Shape 47"/>
+          <p:cNvPr id="50" name="Shape 48"/>
           <p:cNvSpPr/>
           <p:nvPr/>
         </p:nvSpPr>
@@ -9662,7 +9783,7 @@
       </p:sp>
       <p:sp>
         <p:nvSpPr>
-          <p:cNvPr id="50" name="Text 48"/>
+          <p:cNvPr id="51" name="Text 49"/>
           <p:cNvSpPr/>
           <p:nvPr/>
         </p:nvSpPr>
@@ -9698,7 +9819,7 @@
       </p:sp>
       <p:sp>
         <p:nvSpPr>
-          <p:cNvPr id="51" name="Shape 49"/>
+          <p:cNvPr id="52" name="Shape 50"/>
           <p:cNvSpPr/>
           <p:nvPr/>
         </p:nvSpPr>
@@ -9723,7 +9844,7 @@
       </p:sp>
       <p:sp>
         <p:nvSpPr>
-          <p:cNvPr id="52" name="Text 50"/>
+          <p:cNvPr id="53" name="Text 51"/>
           <p:cNvSpPr/>
           <p:nvPr/>
         </p:nvSpPr>
@@ -9759,7 +9880,7 @@
       </p:sp>
       <p:sp>
         <p:nvSpPr>
-          <p:cNvPr id="53" name="Shape 51"/>
+          <p:cNvPr id="54" name="Shape 52"/>
           <p:cNvSpPr/>
           <p:nvPr/>
         </p:nvSpPr>
@@ -9784,7 +9905,7 @@
       </p:sp>
       <p:sp>
         <p:nvSpPr>
-          <p:cNvPr id="54" name="Text 52"/>
+          <p:cNvPr id="55" name="Text 53"/>
           <p:cNvSpPr/>
           <p:nvPr/>
         </p:nvSpPr>
@@ -9820,7 +9941,7 @@
       </p:sp>
       <p:sp>
         <p:nvSpPr>
-          <p:cNvPr id="55" name="Shape 53"/>
+          <p:cNvPr id="56" name="Shape 54"/>
           <p:cNvSpPr/>
           <p:nvPr/>
         </p:nvSpPr>
@@ -9845,7 +9966,7 @@
       </p:sp>
       <p:sp>
         <p:nvSpPr>
-          <p:cNvPr id="56" name="Text 54"/>
+          <p:cNvPr id="57" name="Text 55"/>
           <p:cNvSpPr/>
           <p:nvPr/>
         </p:nvSpPr>
@@ -9881,7 +10002,7 @@
       </p:sp>
       <p:sp>
         <p:nvSpPr>
-          <p:cNvPr id="57" name="Shape 55"/>
+          <p:cNvPr id="58" name="Shape 56"/>
           <p:cNvSpPr/>
           <p:nvPr/>
         </p:nvSpPr>
@@ -9906,7 +10027,7 @@
       </p:sp>
       <p:sp>
         <p:nvSpPr>
-          <p:cNvPr id="58" name="Text 56"/>
+          <p:cNvPr id="59" name="Text 57"/>
           <p:cNvSpPr/>
           <p:nvPr/>
         </p:nvSpPr>
@@ -9942,7 +10063,7 @@
       </p:sp>
       <p:sp>
         <p:nvSpPr>
-          <p:cNvPr id="59" name="Shape 57"/>
+          <p:cNvPr id="60" name="Shape 58"/>
           <p:cNvSpPr/>
           <p:nvPr/>
         </p:nvSpPr>
@@ -9967,7 +10088,7 @@
       </p:sp>
       <p:sp>
         <p:nvSpPr>
-          <p:cNvPr id="60" name="Text 58"/>
+          <p:cNvPr id="61" name="Text 59"/>
           <p:cNvSpPr/>
           <p:nvPr/>
         </p:nvSpPr>
@@ -10003,7 +10124,7 @@
       </p:sp>
       <p:sp>
         <p:nvSpPr>
-          <p:cNvPr id="61" name="Shape 59"/>
+          <p:cNvPr id="62" name="Shape 60"/>
           <p:cNvSpPr/>
           <p:nvPr/>
         </p:nvSpPr>
@@ -10028,7 +10149,7 @@
       </p:sp>
       <p:sp>
         <p:nvSpPr>
-          <p:cNvPr id="62" name="Text 60"/>
+          <p:cNvPr id="63" name="Text 61"/>
           <p:cNvSpPr/>
           <p:nvPr/>
         </p:nvSpPr>
@@ -10064,7 +10185,7 @@
       </p:sp>
       <p:sp>
         <p:nvSpPr>
-          <p:cNvPr id="63" name="Shape 61"/>
+          <p:cNvPr id="64" name="Shape 62"/>
           <p:cNvSpPr/>
           <p:nvPr/>
         </p:nvSpPr>
@@ -10089,7 +10210,7 @@
       </p:sp>
       <p:sp>
         <p:nvSpPr>
-          <p:cNvPr id="64" name="Text 62"/>
+          <p:cNvPr id="65" name="Text 63"/>
           <p:cNvSpPr/>
           <p:nvPr/>
         </p:nvSpPr>
@@ -10125,7 +10246,7 @@
       </p:sp>
       <p:sp>
         <p:nvSpPr>
-          <p:cNvPr id="65" name="Shape 63"/>
+          <p:cNvPr id="66" name="Shape 64"/>
           <p:cNvSpPr/>
           <p:nvPr/>
         </p:nvSpPr>
@@ -10150,7 +10271,7 @@
       </p:sp>
       <p:sp>
         <p:nvSpPr>
-          <p:cNvPr id="66" name="Text 64"/>
+          <p:cNvPr id="67" name="Text 65"/>
           <p:cNvSpPr/>
           <p:nvPr/>
         </p:nvSpPr>
@@ -10186,7 +10307,7 @@
       </p:sp>
       <p:sp>
         <p:nvSpPr>
-          <p:cNvPr id="67" name="Shape 65"/>
+          <p:cNvPr id="68" name="Shape 66"/>
           <p:cNvSpPr/>
           <p:nvPr/>
         </p:nvSpPr>
@@ -10211,7 +10332,7 @@
       </p:sp>
       <p:sp>
         <p:nvSpPr>
-          <p:cNvPr id="68" name="Text 66"/>
+          <p:cNvPr id="69" name="Text 67"/>
           <p:cNvSpPr/>
           <p:nvPr/>
         </p:nvSpPr>
@@ -10247,7 +10368,7 @@
       </p:sp>
       <p:sp>
         <p:nvSpPr>
-          <p:cNvPr id="69" name="Shape 67"/>
+          <p:cNvPr id="70" name="Shape 68"/>
           <p:cNvSpPr/>
           <p:nvPr/>
         </p:nvSpPr>
@@ -10272,7 +10393,7 @@
       </p:sp>
       <p:sp>
         <p:nvSpPr>
-          <p:cNvPr id="70" name="Text 68"/>
+          <p:cNvPr id="71" name="Text 69"/>
           <p:cNvSpPr/>
           <p:nvPr/>
         </p:nvSpPr>
@@ -10308,7 +10429,7 @@
       </p:sp>
       <p:sp>
         <p:nvSpPr>
-          <p:cNvPr id="71" name="Shape 69"/>
+          <p:cNvPr id="72" name="Shape 70"/>
           <p:cNvSpPr/>
           <p:nvPr/>
         </p:nvSpPr>
@@ -10333,7 +10454,7 @@
       </p:sp>
       <p:sp>
         <p:nvSpPr>
-          <p:cNvPr id="72" name="Text 70"/>
+          <p:cNvPr id="73" name="Text 71"/>
           <p:cNvSpPr/>
           <p:nvPr/>
         </p:nvSpPr>
@@ -10369,7 +10490,7 @@
       </p:sp>
       <p:sp>
         <p:nvSpPr>
-          <p:cNvPr id="73" name="Shape 71"/>
+          <p:cNvPr id="74" name="Shape 72"/>
           <p:cNvSpPr/>
           <p:nvPr/>
         </p:nvSpPr>
@@ -10394,7 +10515,7 @@
       </p:sp>
       <p:sp>
         <p:nvSpPr>
-          <p:cNvPr id="74" name="Text 72"/>
+          <p:cNvPr id="75" name="Text 73"/>
           <p:cNvSpPr/>
           <p:nvPr/>
         </p:nvSpPr>
@@ -10430,7 +10551,7 @@
       </p:sp>
       <p:sp>
         <p:nvSpPr>
-          <p:cNvPr id="75" name="Shape 73"/>
+          <p:cNvPr id="76" name="Shape 74"/>
           <p:cNvSpPr/>
           <p:nvPr/>
         </p:nvSpPr>
@@ -10455,7 +10576,7 @@
       </p:sp>
       <p:sp>
         <p:nvSpPr>
-          <p:cNvPr id="76" name="Text 74"/>
+          <p:cNvPr id="77" name="Text 75"/>
           <p:cNvSpPr/>
           <p:nvPr/>
         </p:nvSpPr>
@@ -10491,7 +10612,7 @@
       </p:sp>
       <p:sp>
         <p:nvSpPr>
-          <p:cNvPr id="77" name="Shape 75"/>
+          <p:cNvPr id="78" name="Shape 76"/>
           <p:cNvSpPr/>
           <p:nvPr/>
         </p:nvSpPr>
@@ -10516,7 +10637,7 @@
       </p:sp>
       <p:sp>
         <p:nvSpPr>
-          <p:cNvPr id="78" name="Text 76"/>
+          <p:cNvPr id="79" name="Text 77"/>
           <p:cNvSpPr/>
           <p:nvPr/>
         </p:nvSpPr>
@@ -10552,7 +10673,7 @@
       </p:sp>
       <p:sp>
         <p:nvSpPr>
-          <p:cNvPr id="79" name="Shape 77"/>
+          <p:cNvPr id="80" name="Shape 78"/>
           <p:cNvSpPr/>
           <p:nvPr/>
         </p:nvSpPr>
@@ -10577,7 +10698,7 @@
       </p:sp>
       <p:sp>
         <p:nvSpPr>
-          <p:cNvPr id="80" name="Text 78"/>
+          <p:cNvPr id="81" name="Text 79"/>
           <p:cNvSpPr/>
           <p:nvPr/>
         </p:nvSpPr>
@@ -10613,7 +10734,7 @@
       </p:sp>
       <p:sp>
         <p:nvSpPr>
-          <p:cNvPr id="81" name="Shape 79"/>
+          <p:cNvPr id="82" name="Shape 80"/>
           <p:cNvSpPr/>
           <p:nvPr/>
         </p:nvSpPr>
@@ -10638,7 +10759,7 @@
       </p:sp>
       <p:sp>
         <p:nvSpPr>
-          <p:cNvPr id="82" name="Text 80"/>
+          <p:cNvPr id="83" name="Text 81"/>
           <p:cNvSpPr/>
           <p:nvPr/>
         </p:nvSpPr>
@@ -10674,7 +10795,7 @@
       </p:sp>
       <p:sp>
         <p:nvSpPr>
-          <p:cNvPr id="83" name="Shape 81"/>
+          <p:cNvPr id="84" name="Shape 82"/>
           <p:cNvSpPr/>
           <p:nvPr/>
         </p:nvSpPr>
@@ -10699,7 +10820,7 @@
       </p:sp>
       <p:sp>
         <p:nvSpPr>
-          <p:cNvPr id="84" name="Text 82"/>
+          <p:cNvPr id="85" name="Text 83"/>
           <p:cNvSpPr/>
           <p:nvPr/>
         </p:nvSpPr>
@@ -10735,7 +10856,7 @@
       </p:sp>
       <p:sp>
         <p:nvSpPr>
-          <p:cNvPr id="85" name="Shape 83"/>
+          <p:cNvPr id="86" name="Shape 84"/>
           <p:cNvSpPr/>
           <p:nvPr/>
         </p:nvSpPr>
@@ -10760,7 +10881,7 @@
       </p:sp>
       <p:sp>
         <p:nvSpPr>
-          <p:cNvPr id="86" name="Text 84"/>
+          <p:cNvPr id="87" name="Text 85"/>
           <p:cNvSpPr/>
           <p:nvPr/>
         </p:nvSpPr>
@@ -10796,7 +10917,7 @@
       </p:sp>
       <p:sp>
         <p:nvSpPr>
-          <p:cNvPr id="87" name="Shape 85"/>
+          <p:cNvPr id="88" name="Shape 86"/>
           <p:cNvSpPr/>
           <p:nvPr/>
         </p:nvSpPr>
@@ -10821,7 +10942,7 @@
       </p:sp>
       <p:sp>
         <p:nvSpPr>
-          <p:cNvPr id="88" name="Text 86"/>
+          <p:cNvPr id="89" name="Text 87"/>
           <p:cNvSpPr/>
           <p:nvPr/>
         </p:nvSpPr>
@@ -10857,7 +10978,7 @@
       </p:sp>
       <p:sp>
         <p:nvSpPr>
-          <p:cNvPr id="89" name="Shape 87"/>
+          <p:cNvPr id="90" name="Shape 88"/>
           <p:cNvSpPr/>
           <p:nvPr/>
         </p:nvSpPr>
@@ -10882,7 +11003,7 @@
       </p:sp>
       <p:sp>
         <p:nvSpPr>
-          <p:cNvPr id="90" name="Text 88"/>
+          <p:cNvPr id="91" name="Text 89"/>
           <p:cNvSpPr/>
           <p:nvPr/>
         </p:nvSpPr>
@@ -10918,7 +11039,7 @@
       </p:sp>
       <p:sp>
         <p:nvSpPr>
-          <p:cNvPr id="91" name="Shape 89"/>
+          <p:cNvPr id="92" name="Shape 90"/>
           <p:cNvSpPr/>
           <p:nvPr/>
         </p:nvSpPr>
@@ -10943,7 +11064,7 @@
       </p:sp>
       <p:sp>
         <p:nvSpPr>
-          <p:cNvPr id="92" name="Text 90"/>
+          <p:cNvPr id="93" name="Text 91"/>
           <p:cNvSpPr/>
           <p:nvPr/>
         </p:nvSpPr>
@@ -10979,7 +11100,7 @@
       </p:sp>
       <p:sp>
         <p:nvSpPr>
-          <p:cNvPr id="93" name="Shape 91"/>
+          <p:cNvPr id="94" name="Shape 92"/>
           <p:cNvSpPr/>
           <p:nvPr/>
         </p:nvSpPr>
@@ -11004,7 +11125,7 @@
       </p:sp>
       <p:sp>
         <p:nvSpPr>
-          <p:cNvPr id="94" name="Text 92"/>
+          <p:cNvPr id="95" name="Text 93"/>
           <p:cNvSpPr/>
           <p:nvPr/>
         </p:nvSpPr>
@@ -11040,7 +11161,7 @@
       </p:sp>
       <p:sp>
         <p:nvSpPr>
-          <p:cNvPr id="95" name="Shape 93"/>
+          <p:cNvPr id="96" name="Shape 94"/>
           <p:cNvSpPr/>
           <p:nvPr/>
         </p:nvSpPr>
@@ -11065,7 +11186,7 @@
       </p:sp>
       <p:sp>
         <p:nvSpPr>
-          <p:cNvPr id="96" name="Text 94"/>
+          <p:cNvPr id="97" name="Text 95"/>
           <p:cNvSpPr/>
           <p:nvPr/>
         </p:nvSpPr>
@@ -11101,7 +11222,7 @@
       </p:sp>
       <p:sp>
         <p:nvSpPr>
-          <p:cNvPr id="97" name="Shape 95"/>
+          <p:cNvPr id="98" name="Shape 96"/>
           <p:cNvSpPr/>
           <p:nvPr/>
         </p:nvSpPr>
@@ -11126,7 +11247,7 @@
       </p:sp>
       <p:sp>
         <p:nvSpPr>
-          <p:cNvPr id="98" name="Text 96"/>
+          <p:cNvPr id="99" name="Text 97"/>
           <p:cNvSpPr/>
           <p:nvPr/>
         </p:nvSpPr>
@@ -11162,7 +11283,7 @@
       </p:sp>
       <p:sp>
         <p:nvSpPr>
-          <p:cNvPr id="99" name="Shape 97"/>
+          <p:cNvPr id="100" name="Shape 98"/>
           <p:cNvSpPr/>
           <p:nvPr/>
         </p:nvSpPr>
@@ -11187,7 +11308,7 @@
       </p:sp>
       <p:sp>
         <p:nvSpPr>
-          <p:cNvPr id="100" name="Text 98"/>
+          <p:cNvPr id="101" name="Text 99"/>
           <p:cNvSpPr/>
           <p:nvPr/>
         </p:nvSpPr>
@@ -11223,7 +11344,7 @@
       </p:sp>
       <p:sp>
         <p:nvSpPr>
-          <p:cNvPr id="101" name="Shape 99"/>
+          <p:cNvPr id="102" name="Shape 100"/>
           <p:cNvSpPr/>
           <p:nvPr/>
         </p:nvSpPr>
@@ -11248,7 +11369,7 @@
       </p:sp>
       <p:sp>
         <p:nvSpPr>
-          <p:cNvPr id="102" name="Text 100"/>
+          <p:cNvPr id="103" name="Text 101"/>
           <p:cNvSpPr/>
           <p:nvPr/>
         </p:nvSpPr>
@@ -11284,7 +11405,7 @@
       </p:sp>
       <p:sp>
         <p:nvSpPr>
-          <p:cNvPr id="103" name="Shape 101"/>
+          <p:cNvPr id="104" name="Shape 102"/>
           <p:cNvSpPr/>
           <p:nvPr/>
         </p:nvSpPr>
@@ -11309,7 +11430,7 @@
       </p:sp>
       <p:sp>
         <p:nvSpPr>
-          <p:cNvPr id="104" name="Text 102"/>
+          <p:cNvPr id="105" name="Text 103"/>
           <p:cNvSpPr/>
           <p:nvPr/>
         </p:nvSpPr>
@@ -11345,7 +11466,7 @@
       </p:sp>
       <p:sp>
         <p:nvSpPr>
-          <p:cNvPr id="105" name="Shape 103"/>
+          <p:cNvPr id="106" name="Shape 104"/>
           <p:cNvSpPr/>
           <p:nvPr/>
         </p:nvSpPr>
@@ -11370,7 +11491,7 @@
       </p:sp>
       <p:sp>
         <p:nvSpPr>
-          <p:cNvPr id="106" name="Text 104"/>
+          <p:cNvPr id="107" name="Text 105"/>
           <p:cNvSpPr/>
           <p:nvPr/>
         </p:nvSpPr>
@@ -11406,7 +11527,7 @@
       </p:sp>
       <p:sp>
         <p:nvSpPr>
-          <p:cNvPr id="107" name="Shape 105"/>
+          <p:cNvPr id="108" name="Shape 106"/>
           <p:cNvSpPr/>
           <p:nvPr/>
         </p:nvSpPr>
@@ -11431,7 +11552,7 @@
       </p:sp>
       <p:sp>
         <p:nvSpPr>
-          <p:cNvPr id="108" name="Text 106"/>
+          <p:cNvPr id="109" name="Text 107"/>
           <p:cNvSpPr/>
           <p:nvPr/>
         </p:nvSpPr>
@@ -11467,7 +11588,7 @@
       </p:sp>
       <p:sp>
         <p:nvSpPr>
-          <p:cNvPr id="109" name="Shape 107"/>
+          <p:cNvPr id="110" name="Shape 108"/>
           <p:cNvSpPr/>
           <p:nvPr/>
         </p:nvSpPr>
@@ -11492,7 +11613,7 @@
       </p:sp>
       <p:sp>
         <p:nvSpPr>
-          <p:cNvPr id="110" name="Text 108"/>
+          <p:cNvPr id="111" name="Text 109"/>
           <p:cNvSpPr/>
           <p:nvPr/>
         </p:nvSpPr>
@@ -11528,7 +11649,7 @@
       </p:sp>
       <p:sp>
         <p:nvSpPr>
-          <p:cNvPr id="111" name="Shape 109"/>
+          <p:cNvPr id="112" name="Shape 110"/>
           <p:cNvSpPr/>
           <p:nvPr/>
         </p:nvSpPr>
@@ -11553,7 +11674,7 @@
       </p:sp>
       <p:sp>
         <p:nvSpPr>
-          <p:cNvPr id="112" name="Text 110"/>
+          <p:cNvPr id="113" name="Text 111"/>
           <p:cNvSpPr/>
           <p:nvPr/>
         </p:nvSpPr>
@@ -11589,7 +11710,7 @@
       </p:sp>
       <p:sp>
         <p:nvSpPr>
-          <p:cNvPr id="113" name="Shape 111"/>
+          <p:cNvPr id="114" name="Shape 112"/>
           <p:cNvSpPr/>
           <p:nvPr/>
         </p:nvSpPr>
@@ -11614,7 +11735,7 @@
       </p:sp>
       <p:sp>
         <p:nvSpPr>
-          <p:cNvPr id="114" name="Text 112"/>
+          <p:cNvPr id="115" name="Text 113"/>
           <p:cNvSpPr/>
           <p:nvPr/>
         </p:nvSpPr>
@@ -11650,7 +11771,7 @@
       </p:sp>
       <p:sp>
         <p:nvSpPr>
-          <p:cNvPr id="115" name="Shape 113"/>
+          <p:cNvPr id="116" name="Shape 114"/>
           <p:cNvSpPr/>
           <p:nvPr/>
         </p:nvSpPr>
@@ -11675,7 +11796,7 @@
       </p:sp>
       <p:sp>
         <p:nvSpPr>
-          <p:cNvPr id="116" name="Text 114"/>
+          <p:cNvPr id="117" name="Text 115"/>
           <p:cNvSpPr/>
           <p:nvPr/>
         </p:nvSpPr>
@@ -11711,7 +11832,7 @@
       </p:sp>
       <p:sp>
         <p:nvSpPr>
-          <p:cNvPr id="117" name="Shape 115"/>
+          <p:cNvPr id="118" name="Shape 116"/>
           <p:cNvSpPr/>
           <p:nvPr/>
         </p:nvSpPr>
@@ -11736,7 +11857,7 @@
       </p:sp>
       <p:sp>
         <p:nvSpPr>
-          <p:cNvPr id="118" name="Text 116"/>
+          <p:cNvPr id="119" name="Text 117"/>
           <p:cNvSpPr/>
           <p:nvPr/>
         </p:nvSpPr>
@@ -11772,7 +11893,7 @@
       </p:sp>
       <p:sp>
         <p:nvSpPr>
-          <p:cNvPr id="119" name="Shape 117"/>
+          <p:cNvPr id="120" name="Shape 118"/>
           <p:cNvSpPr/>
           <p:nvPr/>
         </p:nvSpPr>
@@ -11797,7 +11918,7 @@
       </p:sp>
       <p:sp>
         <p:nvSpPr>
-          <p:cNvPr id="120" name="Text 118"/>
+          <p:cNvPr id="121" name="Text 119"/>
           <p:cNvSpPr/>
           <p:nvPr/>
         </p:nvSpPr>
@@ -11833,7 +11954,7 @@
       </p:sp>
       <p:sp>
         <p:nvSpPr>
-          <p:cNvPr id="121" name="Shape 119"/>
+          <p:cNvPr id="122" name="Shape 120"/>
           <p:cNvSpPr/>
           <p:nvPr/>
         </p:nvSpPr>
@@ -11858,7 +11979,7 @@
       </p:sp>
       <p:sp>
         <p:nvSpPr>
-          <p:cNvPr id="122" name="Text 120"/>
+          <p:cNvPr id="123" name="Text 121"/>
           <p:cNvSpPr/>
           <p:nvPr/>
         </p:nvSpPr>
@@ -11894,7 +12015,7 @@
       </p:sp>
       <p:sp>
         <p:nvSpPr>
-          <p:cNvPr id="123" name="Shape 121"/>
+          <p:cNvPr id="124" name="Shape 122"/>
           <p:cNvSpPr/>
           <p:nvPr/>
         </p:nvSpPr>
@@ -11919,7 +12040,7 @@
       </p:sp>
       <p:sp>
         <p:nvSpPr>
-          <p:cNvPr id="124" name="Text 122"/>
+          <p:cNvPr id="125" name="Text 123"/>
           <p:cNvSpPr/>
           <p:nvPr/>
         </p:nvSpPr>
@@ -11955,7 +12076,7 @@
       </p:sp>
       <p:sp>
         <p:nvSpPr>
-          <p:cNvPr id="125" name="Shape 123"/>
+          <p:cNvPr id="126" name="Shape 124"/>
           <p:cNvSpPr/>
           <p:nvPr/>
         </p:nvSpPr>
@@ -11980,7 +12101,7 @@
       </p:sp>
       <p:sp>
         <p:nvSpPr>
-          <p:cNvPr id="126" name="Text 124"/>
+          <p:cNvPr id="127" name="Text 125"/>
           <p:cNvSpPr/>
           <p:nvPr/>
         </p:nvSpPr>
@@ -12016,7 +12137,7 @@
       </p:sp>
       <p:sp>
         <p:nvSpPr>
-          <p:cNvPr id="127" name="Shape 125"/>
+          <p:cNvPr id="128" name="Shape 126"/>
           <p:cNvSpPr/>
           <p:nvPr/>
         </p:nvSpPr>
@@ -12041,7 +12162,7 @@
       </p:sp>
       <p:sp>
         <p:nvSpPr>
-          <p:cNvPr id="128" name="Text 126"/>
+          <p:cNvPr id="129" name="Text 127"/>
           <p:cNvSpPr/>
           <p:nvPr/>
         </p:nvSpPr>
@@ -12077,7 +12198,7 @@
       </p:sp>
       <p:sp>
         <p:nvSpPr>
-          <p:cNvPr id="129" name="Shape 127"/>
+          <p:cNvPr id="130" name="Shape 128"/>
           <p:cNvSpPr/>
           <p:nvPr/>
         </p:nvSpPr>
@@ -12102,7 +12223,7 @@
       </p:sp>
       <p:sp>
         <p:nvSpPr>
-          <p:cNvPr id="130" name="Text 128"/>
+          <p:cNvPr id="131" name="Text 129"/>
           <p:cNvSpPr/>
           <p:nvPr/>
         </p:nvSpPr>
@@ -12138,7 +12259,7 @@
       </p:sp>
       <p:sp>
         <p:nvSpPr>
-          <p:cNvPr id="131" name="Shape 129"/>
+          <p:cNvPr id="132" name="Shape 130"/>
           <p:cNvSpPr/>
           <p:nvPr/>
         </p:nvSpPr>
@@ -12163,7 +12284,7 @@
       </p:sp>
       <p:sp>
         <p:nvSpPr>
-          <p:cNvPr id="132" name="Text 130"/>
+          <p:cNvPr id="133" name="Text 131"/>
           <p:cNvSpPr/>
           <p:nvPr/>
         </p:nvSpPr>
@@ -12199,7 +12320,7 @@
       </p:sp>
       <p:sp>
         <p:nvSpPr>
-          <p:cNvPr id="133" name="Shape 131"/>
+          <p:cNvPr id="134" name="Shape 132"/>
           <p:cNvSpPr/>
           <p:nvPr/>
         </p:nvSpPr>
@@ -12224,7 +12345,7 @@
       </p:sp>
       <p:sp>
         <p:nvSpPr>
-          <p:cNvPr id="134" name="Text 132"/>
+          <p:cNvPr id="135" name="Text 133"/>
           <p:cNvSpPr/>
           <p:nvPr/>
         </p:nvSpPr>
@@ -12260,7 +12381,7 @@
       </p:sp>
       <p:sp>
         <p:nvSpPr>
-          <p:cNvPr id="135" name="Text 133"/>
+          <p:cNvPr id="136" name="Text 134"/>
           <p:cNvSpPr/>
           <p:nvPr/>
         </p:nvSpPr>
@@ -12296,7 +12417,7 @@
       </p:sp>
       <p:sp>
         <p:nvSpPr>
-          <p:cNvPr id="136" name="Text 134"/>
+          <p:cNvPr id="137" name="Text 135"/>
           <p:cNvSpPr/>
           <p:nvPr/>
         </p:nvSpPr>

</xml_diff>

<commit_message>
✅ v4.4 — card Alfonsino allineata, Capterra sotto titolo
</commit_message>
<xml_diff>
--- a/02-INVESTOR-PRESENTATIONS/DLOOP_Pitch_Deck_2026.pptx
+++ b/02-INVESTOR-PRESENTATIONS/DLOOP_Pitch_Deck_2026.pptx
@@ -7912,8 +7912,8 @@
         </p:nvSpPr>
         <p:spPr>
           <a:xfrm>
-            <a:off x="457200" y="4434840"/>
-            <a:ext cx="5577840" cy="868680"/>
+            <a:off x="457200" y="4297680"/>
+            <a:ext cx="5577840" cy="1280160"/>
           </a:xfrm>
           <a:prstGeom prst="rect">
             <a:avLst/>
@@ -7937,8 +7937,8 @@
         </p:nvSpPr>
         <p:spPr>
           <a:xfrm>
-            <a:off x="640080" y="4480560"/>
-            <a:ext cx="5212080" cy="237744"/>
+            <a:off x="640080" y="4352544"/>
+            <a:ext cx="5212080" cy="256032"/>
           </a:xfrm>
           <a:prstGeom prst="rect">
             <a:avLst/>
@@ -8012,8 +8012,8 @@
         </p:nvSpPr>
         <p:spPr>
           <a:xfrm>
-            <a:off x="6309360" y="4434840"/>
-            <a:ext cx="5349240" cy="868680"/>
+            <a:off x="6309360" y="4297680"/>
+            <a:ext cx="5349240" cy="1280160"/>
           </a:xfrm>
           <a:prstGeom prst="rect">
             <a:avLst/>
@@ -8037,8 +8037,8 @@
         </p:nvSpPr>
         <p:spPr>
           <a:xfrm>
-            <a:off x="6492240" y="4480560"/>
-            <a:ext cx="4937760" cy="237744"/>
+            <a:off x="6492240" y="4352544"/>
+            <a:ext cx="4937760" cy="256032"/>
           </a:xfrm>
           <a:prstGeom prst="rect">
             <a:avLst/>
@@ -8073,8 +8073,8 @@
         </p:nvSpPr>
         <p:spPr>
           <a:xfrm>
-            <a:off x="6492240" y="4754880"/>
-            <a:ext cx="4937760" cy="502920"/>
+            <a:off x="6492240" y="4636008"/>
+            <a:ext cx="4937760" cy="822960"/>
           </a:xfrm>
           <a:prstGeom prst="rect">
             <a:avLst/>
@@ -8088,7 +8088,7 @@
           <a:p>
             <a:pPr indent="0" marL="0">
               <a:lnSpc>
-                <a:spcPct val="130000"/>
+                <a:spcPct val="145000"/>
               </a:lnSpc>
               <a:buNone/>
             </a:pPr>
@@ -8255,7 +8255,7 @@
         </p:nvSpPr>
         <p:spPr>
           <a:xfrm>
-            <a:off x="457200" y="1261872"/>
+            <a:off x="457200" y="1481328"/>
             <a:ext cx="11247120" cy="228600"/>
           </a:xfrm>
           <a:prstGeom prst="rect">

</xml_diff>